<commit_message>
feat(ui): sync UI enhancements and onboarding guide into itantra2.0 branch
</commit_message>
<xml_diff>
--- a/iTantra_SIH2026.pptx
+++ b/iTantra_SIH2026.pptx
@@ -2375,7 +2375,7 @@
                 </a:solidFill>
                 <a:latin typeface="Calibri"/>
               </a:rPr>
-              <a:t xml:space="preserve">•  TX measured on 3353f694: 42 B transcript   </a:t>
+              <a:t xml:space="preserve">•  TX on 3353f694 (42 B text):   </a:t>
             </a:r>
             <a:r>
               <a:rPr lang="en-US" sz="1300" dirty="0">
@@ -2384,7 +2384,7 @@
                 </a:solidFill>
                 <a:latin typeface="Calibri"/>
               </a:rPr>
-              <a:t xml:space="preserve">→ 50 B/datagram × 12 FEC shards = 6,600 B/msg (11 broadcast dests) vs 48,000 B PCM ≈7× wire / ≈1,100× at payload.</a:t>
+              <a:t xml:space="preserve">50 B/datagram × 12 FEC shards = 6,600 B/msg (11 broadcast dests) vs 48,000 B PCM → ≈7× wire, ≈1,100× payload (English; Indic ≈3 B/char → 500–800×).</a:t>
             </a:r>
           </a:p>
           <a:p>

</xml_diff>

<commit_message>
docs(deck): correct submission identity to SIH26173 / Algo Avengers
Slide 1 and every template header carried a placeholder identity
(SIH1608, Code-Ons, TEAM iTANTRA, ISRO-01). Replaced with the real
submission values throughout the content source and the generator:

- ppt.md: PS ID SIH26173, PS title from the official statement,
  Team ID 172340, Team Name Algo Avengers, theme ordering.
- build_ppt.py: title banner, per-slide footer and dc:creator.
- regenerated iTantra_SIH2026.pptx.

The technical body is untouched and stays the honest one: the merge
had briefly staged a 9,388-byte copy that reintroduced the <=38 B /
<300 bps / AES-128 / RS(255,223) / CRC32 claims already corrected, so
the committed16,670-byte body was restored and only the header
changed.

Verified in the built deck: 6 slides, SIH26173 x7, Algo Avengers x6,
and zero occurrences of SIH1608 / Code-Ons / ISRO-01 / AES-128 /
RS(255,223) / CRC32 / <300 bps.
</commit_message>
<xml_diff>
--- a/iTantra_SIH2026.pptx
+++ b/iTantra_SIH2026.pptx
@@ -198,7 +198,7 @@
                 </a:solidFill>
                 <a:latin typeface="Calibri"/>
               </a:rPr>
-              <a:t xml:space="preserve">SIH 2026  •  PROBLEM STATEMENT ISRO-01  •  TEAM iTANTRA</a:t>
+              <a:t xml:space="preserve">SIH 2026  •  PROBLEM STATEMENT SIH26173  •  TEAM ALGO AVENGERS</a:t>
             </a:r>
           </a:p>
         </p:txBody>
@@ -464,7 +464,7 @@
                 </a:solidFill>
                 <a:latin typeface="Calibri"/>
               </a:rPr>
-              <a:t xml:space="preserve">Team iTantra  •  SIH2026 / ISRO-01  •  1 / 6</a:t>
+              <a:t xml:space="preserve">Algo Avengers  •  SIH26173 / ISRO  •  1 / 6</a:t>
             </a:r>
           </a:p>
         </p:txBody>
@@ -1632,7 +1632,7 @@
                 </a:solidFill>
                 <a:latin typeface="Calibri"/>
               </a:rPr>
-              <a:t xml:space="preserve">Team iTantra  •  SIH2026 / ISRO-01  •  2 / 6</a:t>
+              <a:t xml:space="preserve">Algo Avengers  •  SIH26173 / ISRO  •  2 / 6</a:t>
             </a:r>
           </a:p>
         </p:txBody>
@@ -2118,7 +2118,7 @@
                 </a:solidFill>
                 <a:latin typeface="Calibri"/>
               </a:rPr>
-              <a:t xml:space="preserve">Team iTantra  •  SIH2026 / ISRO-01  •  3 / 6</a:t>
+              <a:t xml:space="preserve">Algo Avengers  •  SIH26173 / ISRO  •  3 / 6</a:t>
             </a:r>
           </a:p>
         </p:txBody>
@@ -2652,7 +2652,7 @@
                 </a:solidFill>
                 <a:latin typeface="Calibri"/>
               </a:rPr>
-              <a:t xml:space="preserve">Team iTantra  •  SIH2026 / ISRO-01  •  4 / 6</a:t>
+              <a:t xml:space="preserve">Algo Avengers  •  SIH26173 / ISRO  •  4 / 6</a:t>
             </a:r>
           </a:p>
         </p:txBody>
@@ -3094,7 +3094,7 @@
                 </a:solidFill>
                 <a:latin typeface="Calibri"/>
               </a:rPr>
-              <a:t xml:space="preserve">Team iTantra  •  SIH2026 / ISRO-01  •  5 / 6</a:t>
+              <a:t xml:space="preserve">Algo Avengers  •  SIH26173 / ISRO  •  5 / 6</a:t>
             </a:r>
           </a:p>
         </p:txBody>
@@ -3524,7 +3524,7 @@
                 </a:solidFill>
                 <a:latin typeface="Calibri"/>
               </a:rPr>
-              <a:t xml:space="preserve">Team iTantra  •  SIH2026 / ISRO-01  •  6 / 6</a:t>
+              <a:t xml:space="preserve">Algo Avengers  •  SIH26173 / ISRO  •  6 / 6</a:t>
             </a:r>
           </a:p>
         </p:txBody>

</xml_diff>